<commit_message>
Fix English PPT: remove all Chinese characters, fix font references
</commit_message>
<xml_diff>
--- a/AMA-终汇报-PPT-English.pptx
+++ b/AMA-终汇报-PPT-English.pptx
@@ -9391,7 +9391,7 @@
                   <a:srgbClr val="FFFFFF"/>
                 </a:solidFill>
               </a:rPr>
-              <a:t>谢谢</a:t>
+              <a:t>Thank You</a:t>
             </a:r>
             <a:endParaRPr lang="en-US" sz="4000" dirty="0"/>
           </a:p>
@@ -11537,8 +11537,8 @@
         <a:cs typeface=""/>
         <a:font script="Jpan" typeface="游ゴシック Light"/>
         <a:font script="Hang" typeface="맑은 고딕"/>
-        <a:font script="Hans" typeface="等线 Light"/>
-        <a:font script="Hant" typeface="新細明體"/>
+        <a:font script="Hans" typeface="Arial Light"/>
+        <a:font script="Hant" typeface="Arial"/>
         <a:font script="Arab" typeface="Times New Roman"/>
         <a:font script="Hebr" typeface="Times New Roman"/>
         <a:font script="Thai" typeface="Angsana New"/>
@@ -11589,8 +11589,8 @@
         <a:cs typeface=""/>
         <a:font script="Jpan" typeface="游ゴシック"/>
         <a:font script="Hang" typeface="맑은 고딕"/>
-        <a:font script="Hans" typeface="等线"/>
-        <a:font script="Hant" typeface="新細明體"/>
+        <a:font script="Hans" typeface="Arial"/>
+        <a:font script="Hant" typeface="Arial"/>
         <a:font script="Arab" typeface="Arial"/>
         <a:font script="Hebr" typeface="Arial"/>
         <a:font script="Thai" typeface="Cordia New"/>

</xml_diff>

<commit_message>
Regenerate both PPTs: remove course refs (TT203), fix CAIP branding
</commit_message>
<xml_diff>
--- a/AMA-终汇报-PPT-English.pptx
+++ b/AMA-终汇报-PPT-English.pptx
@@ -3316,7 +3316,7 @@
               </a:defRPr>
             </a:pPr>
             <a:r>
-              <a:t>Presenter: Yuan Wang  |  Senior Solution Engineer</a:t>
+              <a:t>Presenter: Yuan Wang  |  Senior Solution Engineer, CAIP</a:t>
             </a:r>
           </a:p>
           <a:p>
@@ -3614,7 +3614,7 @@
               </a:defRPr>
             </a:pPr>
             <a:r>
-              <a:t>• Tech: TT203 three-layer architecture (Data → ML → LLM)</a:t>
+              <a:t>• Tech: Three-Layer Architecture（Data → ML → LLM）</a:t>
             </a:r>
           </a:p>
           <a:p>
@@ -3727,7 +3727,7 @@
               </a:defRPr>
             </a:pPr>
             <a:r>
-              <a:t>TT203 Three-Layer</a:t>
+              <a:t>Three-Layer Architecture</a:t>
             </a:r>
           </a:p>
         </p:txBody>
@@ -9204,7 +9204,7 @@
             </a:r>
             <a:br/>
             <a:r>
-              <a:t>TT203 three-layer architecture decision</a:t>
+              <a:t>Three-Layer Architecture decision</a:t>
             </a:r>
           </a:p>
         </p:txBody>
@@ -14688,7 +14688,7 @@
               </a:defRPr>
             </a:pPr>
             <a:r>
-              <a:t>Presenter: Yuan Wang  |  Senior Solution Engineer</a:t>
+              <a:t>Presenter: Yuan Wang  |  Senior Solution Engineer, CAIP</a:t>
             </a:r>
           </a:p>
           <a:p>

</xml_diff>